<commit_message>
fix(remediation): audit fixes for about page, evaluate safeguard, upload memory bounds, and report formatting
</commit_message>
<xml_diff>
--- a/reports/presentation.pptx
+++ b/reports/presentation.pptx
@@ -3243,7 +3243,7 @@
                 </a:solidFill>
                 <a:latin typeface="Calibri"/>
               </a:rPr>
-              <a:t>NeuroSight-E5 · 5-seed ensemble · model card 2026-09-17 · report 2026-09-26</a:t>
+              <a:t>NeuroSight-E5 · 5-seed ensemble · model card 2026-09-17 · report 2026-10-21</a:t>
             </a:r>
           </a:p>
         </p:txBody>
@@ -4231,7 +4231,7 @@
                 </a:solidFill>
                 <a:latin typeface="Calibri"/>
               </a:rPr>
-              <a:t>NeuroSight AI · neurosight-e5 · report 2026-09-26</a:t>
+              <a:t>NeuroSight AI · neurosight-e5 · report 2026-10-21</a:t>
             </a:r>
           </a:p>
         </p:txBody>

</xml_diff>